<commit_message>
Add a 9-slide brief version of the condensed deck
make_deck_condensed.py --brief writes presentations/prFBA_brief_2026-10.pptx: the worked
amplicon, the validation arms and PICRUSt2's two runs, then where the genus calls land, why
they fail, the controlled comparison, the phenotypes and the summary. Same loader, figures
and slide functions as the 17-slide version.

Co-Authored-By: Claude Opus 5.5 <noreply@anthropic.com>
</commit_message>
<xml_diff>
--- a/presentations/prFBA_condensed_2026-10.pptx
+++ b/presentations/prFBA_condensed_2026-10.pptx
@@ -3160,7 +3160,7 @@
           <a:lstStyle/>
           <a:p>
             <a:r>
-              <a:t>A condensed version of the October update deck: four slides of method, each built on one figure, then the validation results. Every benchmark number is at the standard record depth of 100 hits under the shipped exact-tie union selection rule, and every value is read from the pipeline's result files by the same loader the full deck uses. The full deck carries the alignment engineering, the C12 diagnosis, the depth and rule decisions, the MAG build details and the audit trail.</a:t>
+              <a:t>A condensed version of the October update deck: the method, each slide built on one figure, then the validation results. Every benchmark number is at the standard record depth of 100 hits under the shipped exact-tie union selection rule, and every value is read from the pipeline's result files by the same loader the full deck uses. The full deck carries the alignment engineering, the C12 diagnosis, the depth and rule decisions, the MAG build details and the audit trail.</a:t>
             </a:r>
           </a:p>
         </p:txBody>
@@ -7265,7 +7265,7 @@
                 </a:solidFill>
                 <a:latin typeface="Calibri"/>
               </a:rPr>
-              <a:t>The method in four figures</a:t>
+              <a:t>One amplicon, end to end</a:t>
             </a:r>
           </a:p>
         </p:txBody>

</xml_diff>